<commit_message>
update kafka&zeppelin introduction slides
</commit_message>
<xml_diff>
--- a/Presentation.pptx
+++ b/Presentation.pptx
@@ -13547,6 +13547,58 @@
           </a:extLst>
         </p:spPr>
       </p:pic>
+      <p:sp>
+        <p:nvSpPr>
+          <p:cNvPr id="5" name="Rectangle 4">
+            <a:extLst>
+              <a:ext uri="{FF2B5EF4-FFF2-40B4-BE49-F238E27FC236}">
+                <a16:creationId xmlns:a16="http://schemas.microsoft.com/office/drawing/2014/main" id="{AC83B51F-9E8E-4B07-81EB-C6F738E9EAC6}"/>
+              </a:ext>
+            </a:extLst>
+          </p:cNvPr>
+          <p:cNvSpPr/>
+          <p:nvPr/>
+        </p:nvSpPr>
+        <p:spPr>
+          <a:xfrm>
+            <a:off x="5012267" y="1693333"/>
+            <a:ext cx="824089" cy="4472594"/>
+          </a:xfrm>
+          <a:prstGeom prst="rect">
+            <a:avLst/>
+          </a:prstGeom>
+          <a:solidFill>
+            <a:schemeClr val="bg1"/>
+          </a:solidFill>
+          <a:ln>
+            <a:noFill/>
+          </a:ln>
+        </p:spPr>
+        <p:style>
+          <a:lnRef idx="2">
+            <a:schemeClr val="accent1">
+              <a:shade val="50000"/>
+            </a:schemeClr>
+          </a:lnRef>
+          <a:fillRef idx="1">
+            <a:schemeClr val="accent1"/>
+          </a:fillRef>
+          <a:effectRef idx="0">
+            <a:schemeClr val="accent1"/>
+          </a:effectRef>
+          <a:fontRef idx="minor">
+            <a:schemeClr val="lt1"/>
+          </a:fontRef>
+        </p:style>
+        <p:txBody>
+          <a:bodyPr rtlCol="0" anchor="ctr"/>
+          <a:lstStyle/>
+          <a:p>
+            <a:pPr algn="ctr"/>
+            <a:endParaRPr lang="en-GB"/>
+          </a:p>
+        </p:txBody>
+      </p:sp>
     </p:spTree>
     <p:extLst>
       <p:ext uri="{BB962C8B-B14F-4D97-AF65-F5344CB8AC3E}">
@@ -13557,6 +13609,84 @@
   <p:clrMapOvr>
     <a:masterClrMapping/>
   </p:clrMapOvr>
+  <p:timing>
+    <p:tnLst>
+      <p:par>
+        <p:cTn id="1" dur="indefinite" restart="never" nodeType="tmRoot">
+          <p:childTnLst>
+            <p:seq concurrent="1" nextAc="seek">
+              <p:cTn id="2" dur="indefinite" nodeType="mainSeq">
+                <p:childTnLst>
+                  <p:par>
+                    <p:cTn id="3" fill="hold">
+                      <p:stCondLst>
+                        <p:cond delay="indefinite"/>
+                      </p:stCondLst>
+                      <p:childTnLst>
+                        <p:par>
+                          <p:cTn id="4" fill="hold">
+                            <p:stCondLst>
+                              <p:cond delay="0"/>
+                            </p:stCondLst>
+                            <p:childTnLst>
+                              <p:par>
+                                <p:cTn id="5" presetID="1" presetClass="exit" presetSubtype="0" fill="hold" grpId="0" nodeType="clickEffect">
+                                  <p:stCondLst>
+                                    <p:cond delay="0"/>
+                                  </p:stCondLst>
+                                  <p:childTnLst>
+                                    <p:set>
+                                      <p:cBhvr>
+                                        <p:cTn id="6" dur="1" fill="hold">
+                                          <p:stCondLst>
+                                            <p:cond delay="0"/>
+                                          </p:stCondLst>
+                                        </p:cTn>
+                                        <p:tgtEl>
+                                          <p:spTgt spid="5"/>
+                                        </p:tgtEl>
+                                        <p:attrNameLst>
+                                          <p:attrName>style.visibility</p:attrName>
+                                        </p:attrNameLst>
+                                      </p:cBhvr>
+                                      <p:to>
+                                        <p:strVal val="hidden"/>
+                                      </p:to>
+                                    </p:set>
+                                  </p:childTnLst>
+                                </p:cTn>
+                              </p:par>
+                            </p:childTnLst>
+                          </p:cTn>
+                        </p:par>
+                      </p:childTnLst>
+                    </p:cTn>
+                  </p:par>
+                </p:childTnLst>
+              </p:cTn>
+              <p:prevCondLst>
+                <p:cond evt="onPrev" delay="0">
+                  <p:tgtEl>
+                    <p:sldTgt/>
+                  </p:tgtEl>
+                </p:cond>
+              </p:prevCondLst>
+              <p:nextCondLst>
+                <p:cond evt="onNext" delay="0">
+                  <p:tgtEl>
+                    <p:sldTgt/>
+                  </p:tgtEl>
+                </p:cond>
+              </p:nextCondLst>
+            </p:seq>
+          </p:childTnLst>
+        </p:cTn>
+      </p:par>
+    </p:tnLst>
+    <p:bldLst>
+      <p:bldP spid="5" grpId="0" animBg="1"/>
+    </p:bldLst>
+  </p:timing>
 </p:sld>
 </file>
 
@@ -13606,7 +13736,7 @@
         </p:blipFill>
         <p:spPr bwMode="auto">
           <a:xfrm>
-            <a:off x="1337733" y="1640928"/>
+            <a:off x="1337733" y="1928521"/>
             <a:ext cx="8613423" cy="4897984"/>
           </a:xfrm>
           <a:prstGeom prst="rect">
@@ -13725,13 +13855,20 @@
         </p:nvSpPr>
         <p:spPr>
           <a:xfrm>
-            <a:off x="1896533" y="2590142"/>
-            <a:ext cx="1422401" cy="369332"/>
+            <a:off x="1337733" y="2590142"/>
+            <a:ext cx="1805517" cy="646331"/>
           </a:xfrm>
           <a:prstGeom prst="rect">
             <a:avLst/>
           </a:prstGeom>
           <a:noFill/>
+          <a:ln>
+            <a:solidFill>
+              <a:schemeClr val="accent1">
+                <a:shade val="50000"/>
+              </a:schemeClr>
+            </a:solidFill>
+          </a:ln>
         </p:spPr>
         <p:txBody>
           <a:bodyPr wrap="square" rtlCol="0">
@@ -13747,6 +13884,8 @@
               </a:rPr>
               <a:t>Code section</a:t>
             </a:r>
+          </a:p>
+          <a:p>
             <a:endParaRPr lang="en-GB" dirty="0">
               <a:solidFill>
                 <a:srgbClr val="00B050"/>
@@ -13769,13 +13908,18 @@
         </p:nvSpPr>
         <p:spPr>
           <a:xfrm>
-            <a:off x="6304844" y="5411013"/>
-            <a:ext cx="1766712" cy="369332"/>
+            <a:off x="6951447" y="3494028"/>
+            <a:ext cx="2871121" cy="369332"/>
           </a:xfrm>
           <a:prstGeom prst="rect">
             <a:avLst/>
           </a:prstGeom>
-          <a:noFill/>
+          <a:solidFill>
+            <a:schemeClr val="bg1"/>
+          </a:solidFill>
+          <a:ln>
+            <a:noFill/>
+          </a:ln>
         </p:spPr>
         <p:txBody>
           <a:bodyPr wrap="square" rtlCol="0">
@@ -13813,8 +13957,59 @@
         </p:nvSpPr>
         <p:spPr>
           <a:xfrm>
-            <a:off x="9556045" y="2590142"/>
-            <a:ext cx="1298222" cy="369332"/>
+            <a:off x="8121473" y="2590142"/>
+            <a:ext cx="2022651" cy="369332"/>
+          </a:xfrm>
+          <a:prstGeom prst="rect">
+            <a:avLst/>
+          </a:prstGeom>
+          <a:noFill/>
+          <a:ln>
+            <a:solidFill>
+              <a:schemeClr val="accent1">
+                <a:shade val="50000"/>
+              </a:schemeClr>
+            </a:solidFill>
+          </a:ln>
+        </p:spPr>
+        <p:txBody>
+          <a:bodyPr wrap="square" rtlCol="0">
+            <a:spAutoFit/>
+          </a:bodyPr>
+          <a:lstStyle/>
+          <a:p>
+            <a:r>
+              <a:rPr lang="en-US" dirty="0">
+                <a:solidFill>
+                  <a:srgbClr val="00B050"/>
+                </a:solidFill>
+              </a:rPr>
+              <a:t>Commands</a:t>
+            </a:r>
+            <a:endParaRPr lang="en-GB" dirty="0">
+              <a:solidFill>
+                <a:srgbClr val="00B050"/>
+              </a:solidFill>
+            </a:endParaRPr>
+          </a:p>
+        </p:txBody>
+      </p:sp>
+      <p:sp>
+        <p:nvSpPr>
+          <p:cNvPr id="8" name="TextBox 7">
+            <a:extLst>
+              <a:ext uri="{FF2B5EF4-FFF2-40B4-BE49-F238E27FC236}">
+                <a16:creationId xmlns:a16="http://schemas.microsoft.com/office/drawing/2014/main" id="{00517EB6-3976-4564-B2C1-A362D85F3859}"/>
+              </a:ext>
+            </a:extLst>
+          </p:cNvPr>
+          <p:cNvSpPr txBox="1"/>
+          <p:nvPr/>
+        </p:nvSpPr>
+        <p:spPr>
+          <a:xfrm>
+            <a:off x="1337733" y="1469205"/>
+            <a:ext cx="5391680" cy="430887"/>
           </a:xfrm>
           <a:prstGeom prst="rect">
             <a:avLst/>
@@ -13830,64 +14025,145 @@
           <a:lstStyle/>
           <a:p>
             <a:r>
-              <a:rPr lang="en-US" dirty="0">
-                <a:solidFill>
-                  <a:srgbClr val="00B050"/>
-                </a:solidFill>
-              </a:rPr>
-              <a:t>Commands</a:t>
-            </a:r>
-            <a:endParaRPr lang="en-GB" dirty="0">
-              <a:solidFill>
-                <a:srgbClr val="00B050"/>
-              </a:solidFill>
-            </a:endParaRPr>
-          </a:p>
-        </p:txBody>
-      </p:sp>
-      <p:sp>
-        <p:nvSpPr>
-          <p:cNvPr id="8" name="TextBox 7">
-            <a:extLst>
-              <a:ext uri="{FF2B5EF4-FFF2-40B4-BE49-F238E27FC236}">
-                <a16:creationId xmlns:a16="http://schemas.microsoft.com/office/drawing/2014/main" id="{00517EB6-3976-4564-B2C1-A362D85F3859}"/>
-              </a:ext>
-            </a:extLst>
-          </p:cNvPr>
-          <p:cNvSpPr txBox="1"/>
-          <p:nvPr/>
-        </p:nvSpPr>
-        <p:spPr>
-          <a:xfrm>
-            <a:off x="4199467" y="1631833"/>
-            <a:ext cx="2105377" cy="430887"/>
-          </a:xfrm>
-          <a:prstGeom prst="rect">
-            <a:avLst/>
-          </a:prstGeom>
-          <a:solidFill>
-            <a:schemeClr val="bg1"/>
-          </a:solidFill>
-        </p:spPr>
-        <p:txBody>
-          <a:bodyPr wrap="square" rtlCol="0">
-            <a:spAutoFit/>
-          </a:bodyPr>
-          <a:lstStyle/>
-          <a:p>
-            <a:r>
               <a:rPr lang="en-US" sz="2200" dirty="0">
                 <a:solidFill>
                   <a:srgbClr val="00B050"/>
                 </a:solidFill>
               </a:rPr>
-              <a:t>Web-based UI</a:t>
+              <a:t>Web-based UI (localhost:8080 by default)</a:t>
             </a:r>
             <a:endParaRPr lang="en-GB" sz="2200" dirty="0">
               <a:solidFill>
                 <a:srgbClr val="00B050"/>
               </a:solidFill>
             </a:endParaRPr>
+          </a:p>
+        </p:txBody>
+      </p:sp>
+      <p:sp>
+        <p:nvSpPr>
+          <p:cNvPr id="5" name="Rectangle 4">
+            <a:extLst>
+              <a:ext uri="{FF2B5EF4-FFF2-40B4-BE49-F238E27FC236}">
+                <a16:creationId xmlns:a16="http://schemas.microsoft.com/office/drawing/2014/main" id="{8205A4F3-8657-49D6-863A-BAE1BEA58E68}"/>
+              </a:ext>
+            </a:extLst>
+          </p:cNvPr>
+          <p:cNvSpPr/>
+          <p:nvPr/>
+        </p:nvSpPr>
+        <p:spPr>
+          <a:xfrm>
+            <a:off x="6951447" y="3494028"/>
+            <a:ext cx="2999709" cy="2992497"/>
+          </a:xfrm>
+          <a:prstGeom prst="rect">
+            <a:avLst/>
+          </a:prstGeom>
+          <a:noFill/>
+        </p:spPr>
+        <p:style>
+          <a:lnRef idx="2">
+            <a:schemeClr val="accent1">
+              <a:shade val="50000"/>
+            </a:schemeClr>
+          </a:lnRef>
+          <a:fillRef idx="1">
+            <a:schemeClr val="accent1"/>
+          </a:fillRef>
+          <a:effectRef idx="0">
+            <a:schemeClr val="accent1"/>
+          </a:effectRef>
+          <a:fontRef idx="minor">
+            <a:schemeClr val="lt1"/>
+          </a:fontRef>
+        </p:style>
+        <p:txBody>
+          <a:bodyPr rtlCol="0" anchor="ctr"/>
+          <a:lstStyle/>
+          <a:p>
+            <a:pPr algn="ctr"/>
+            <a:endParaRPr lang="en-GB"/>
+          </a:p>
+        </p:txBody>
+      </p:sp>
+      <p:sp>
+        <p:nvSpPr>
+          <p:cNvPr id="10" name="Left Brace 9">
+            <a:extLst>
+              <a:ext uri="{FF2B5EF4-FFF2-40B4-BE49-F238E27FC236}">
+                <a16:creationId xmlns:a16="http://schemas.microsoft.com/office/drawing/2014/main" id="{BFF70947-F17A-40A5-9202-7AA029D97F36}"/>
+              </a:ext>
+            </a:extLst>
+          </p:cNvPr>
+          <p:cNvSpPr/>
+          <p:nvPr/>
+        </p:nvSpPr>
+        <p:spPr>
+          <a:xfrm flipH="1">
+            <a:off x="10215559" y="2243138"/>
+            <a:ext cx="431345" cy="4243387"/>
+          </a:xfrm>
+          <a:prstGeom prst="leftBrace">
+            <a:avLst/>
+          </a:prstGeom>
+        </p:spPr>
+        <p:style>
+          <a:lnRef idx="1">
+            <a:schemeClr val="accent1"/>
+          </a:lnRef>
+          <a:fillRef idx="0">
+            <a:schemeClr val="accent1"/>
+          </a:fillRef>
+          <a:effectRef idx="0">
+            <a:schemeClr val="accent1"/>
+          </a:effectRef>
+          <a:fontRef idx="minor">
+            <a:schemeClr val="tx1"/>
+          </a:fontRef>
+        </p:style>
+        <p:txBody>
+          <a:bodyPr rtlCol="0" anchor="ctr"/>
+          <a:lstStyle/>
+          <a:p>
+            <a:pPr algn="ctr"/>
+            <a:endParaRPr lang="en-GB"/>
+          </a:p>
+        </p:txBody>
+      </p:sp>
+      <p:sp>
+        <p:nvSpPr>
+          <p:cNvPr id="11" name="TextBox 10">
+            <a:extLst>
+              <a:ext uri="{FF2B5EF4-FFF2-40B4-BE49-F238E27FC236}">
+                <a16:creationId xmlns:a16="http://schemas.microsoft.com/office/drawing/2014/main" id="{151CABD6-B6A0-46C8-A138-08B5BE9BD0CB}"/>
+              </a:ext>
+            </a:extLst>
+          </p:cNvPr>
+          <p:cNvSpPr txBox="1"/>
+          <p:nvPr/>
+        </p:nvSpPr>
+        <p:spPr>
+          <a:xfrm>
+            <a:off x="10646904" y="4041665"/>
+            <a:ext cx="1285965" cy="646331"/>
+          </a:xfrm>
+          <a:prstGeom prst="rect">
+            <a:avLst/>
+          </a:prstGeom>
+          <a:noFill/>
+        </p:spPr>
+        <p:txBody>
+          <a:bodyPr wrap="square" rtlCol="0">
+            <a:spAutoFit/>
+          </a:bodyPr>
+          <a:lstStyle/>
+          <a:p>
+            <a:r>
+              <a:rPr lang="en-US" dirty="0"/>
+              <a:t>Multiple paragraphs</a:t>
+            </a:r>
+            <a:endParaRPr lang="en-GB" dirty="0"/>
           </a:p>
         </p:txBody>
       </p:sp>
@@ -18872,6 +19148,15 @@
 </file>
 
 <file path=customXml/item2.xml><?xml version="1.0" encoding="utf-8"?>
+<?mso-contentType ?>
+<FormTemplates xmlns="http://schemas.microsoft.com/sharepoint/v3/contenttype/forms">
+  <Display>DocumentLibraryForm</Display>
+  <Edit>DocumentLibraryForm</Edit>
+  <New>DocumentLibraryForm</New>
+</FormTemplates>
+</file>
+
+<file path=customXml/item3.xml><?xml version="1.0" encoding="utf-8"?>
 <ct:contentTypeSchema xmlns:ct="http://schemas.microsoft.com/office/2006/metadata/contentType" xmlns:ma="http://schemas.microsoft.com/office/2006/metadata/properties/metaAttributes" ct:_="" ma:_="" ma:contentTypeName="Document" ma:contentTypeID="0x01010079F111ED35F8CC479449609E8A0923A6" ma:contentTypeVersion="11" ma:contentTypeDescription="Create a new document." ma:contentTypeScope="" ma:versionID="96291512c1ee715ab617f4c07df79fc1">
   <xsd:schema xmlns:xsd="http://www.w3.org/2001/XMLSchema" xmlns:xs="http://www.w3.org/2001/XMLSchema" xmlns:p="http://schemas.microsoft.com/office/2006/metadata/properties" xmlns:ns2="71af3243-3dd4-4a8d-8c0d-dd76da1f02a5" xmlns:ns3="16c05727-aa75-4e4a-9b5f-8a80a1165891" targetNamespace="http://schemas.microsoft.com/office/2006/metadata/properties" ma:root="true" ma:fieldsID="8256c27c40ca5c40ce1cf6c44f0205df" ns2:_="" ns3:_="">
     <xsd:import namespace="71af3243-3dd4-4a8d-8c0d-dd76da1f02a5"/>
@@ -19082,15 +19367,6 @@
 </ct:contentTypeSchema>
 </file>
 
-<file path=customXml/item3.xml><?xml version="1.0" encoding="utf-8"?>
-<?mso-contentType ?>
-<FormTemplates xmlns="http://schemas.microsoft.com/sharepoint/v3/contenttype/forms">
-  <Display>DocumentLibraryForm</Display>
-  <Edit>DocumentLibraryForm</Edit>
-  <New>DocumentLibraryForm</New>
-</FormTemplates>
-</file>
-
 <file path=customXml/itemProps1.xml><?xml version="1.0" encoding="utf-8"?>
 <ds:datastoreItem xmlns:ds="http://schemas.openxmlformats.org/officeDocument/2006/customXml" ds:itemID="{C87F4215-C6BB-44A3-9A5E-9446E6835900}">
   <ds:schemaRefs>
@@ -19102,6 +19378,14 @@
 </file>
 
 <file path=customXml/itemProps2.xml><?xml version="1.0" encoding="utf-8"?>
+<ds:datastoreItem xmlns:ds="http://schemas.openxmlformats.org/officeDocument/2006/customXml" ds:itemID="{A80A5AF1-8C57-4290-936E-5FD27C957251}">
+  <ds:schemaRefs>
+    <ds:schemaRef ds:uri="http://schemas.microsoft.com/sharepoint/v3/contenttype/forms"/>
+  </ds:schemaRefs>
+</ds:datastoreItem>
+</file>
+
+<file path=customXml/itemProps3.xml><?xml version="1.0" encoding="utf-8"?>
 <ds:datastoreItem xmlns:ds="http://schemas.openxmlformats.org/officeDocument/2006/customXml" ds:itemID="{8F8919DE-9BD9-47A9-9F5D-16EBB9687974}">
   <ds:schemaRefs>
     <ds:schemaRef ds:uri="http://schemas.microsoft.com/office/2006/metadata/contentType"/>
@@ -19118,12 +19402,4 @@
     <ds:schemaRef ds:uri="http://schemas.microsoft.com/internal/obd"/>
   </ds:schemaRefs>
 </ds:datastoreItem>
-</file>
-
-<file path=customXml/itemProps3.xml><?xml version="1.0" encoding="utf-8"?>
-<ds:datastoreItem xmlns:ds="http://schemas.openxmlformats.org/officeDocument/2006/customXml" ds:itemID="{A80A5AF1-8C57-4290-936E-5FD27C957251}">
-  <ds:schemaRefs>
-    <ds:schemaRef ds:uri="http://schemas.microsoft.com/sharepoint/v3/contenttype/forms"/>
-  </ds:schemaRefs>
-</ds:datastoreItem>
 </file>
</xml_diff>